<commit_message>
added management and HCI slides
</commit_message>
<xml_diff>
--- a/HCI/3rd Tutorial/updated Diagrammatic Dialog Design Notations & Computer Mediated Communications (1) (1).pptx
+++ b/HCI/3rd Tutorial/updated Diagrammatic Dialog Design Notations & Computer Mediated Communications (1) (1).pptx
@@ -284,7 +284,7 @@
       <p15:sldGuideLst xmlns:p15="http://schemas.microsoft.com/office/powerpoint/2012/main"/>
     </p:ext>
     <p:ext uri="GoogleSlidesCustomDataVersion2">
-      <go:slidesCustomData xmlns="" xmlns:mc="http://schemas.openxmlformats.org/markup-compatibility/2006" xmlns:mv="urn:schemas-microsoft-com:mac:vml" xmlns:c="http://schemas.openxmlformats.org/drawingml/2006/chart" xmlns:dgm="http://schemas.openxmlformats.org/drawingml/2006/diagram" xmlns:o="urn:schemas-microsoft-com:office:office" xmlns:v="urn:schemas-microsoft-com:vml" xmlns:pvml="urn:schemas-microsoft-com:office:powerpoint" xmlns:com="http://schemas.openxmlformats.org/drawingml/2006/compatibility" xmlns:p14="http://schemas.microsoft.com/office/powerpoint/2010/main" xmlns:p15="http://schemas.microsoft.com/office/powerpoint/2012/main" xmlns:ahyp="http://schemas.microsoft.com/office/drawing/2018/hyperlinkcolor" xmlns:go="http://customooxmlschemas.google.com/" r:id="rId42" roundtripDataSignature="AMtx7mitNAdnJmewx8QbmBYeZpdswOjo/g=="/>
+      <go:slidesCustomData xmlns:go="http://customooxmlschemas.google.com/" xmlns:ahyp="http://schemas.microsoft.com/office/drawing/2018/hyperlinkcolor" xmlns:p15="http://schemas.microsoft.com/office/powerpoint/2012/main" xmlns:p14="http://schemas.microsoft.com/office/powerpoint/2010/main" xmlns:com="http://schemas.openxmlformats.org/drawingml/2006/compatibility" xmlns:pvml="urn:schemas-microsoft-com:office:powerpoint" xmlns:v="urn:schemas-microsoft-com:vml" xmlns:o="urn:schemas-microsoft-com:office:office" xmlns:dgm="http://schemas.openxmlformats.org/drawingml/2006/diagram" xmlns:c="http://schemas.openxmlformats.org/drawingml/2006/chart" xmlns:mv="urn:schemas-microsoft-com:mac:vml" xmlns:mc="http://schemas.openxmlformats.org/markup-compatibility/2006" xmlns="" r:id="rId42" roundtripDataSignature="AMtx7mitNAdnJmewx8QbmBYeZpdswOjo/g=="/>
     </p:ext>
   </p:extLst>
 </p:presentation>
@@ -13122,22 +13122,14 @@
               </a:rPr>
               <a:t> (also called state transition diagrams), which are commonly used in user interface design and modeling user actions. </a:t>
             </a:r>
-            <a:endParaRPr lang="en-US" sz="1800" dirty="0" smtClean="0">
-              <a:latin typeface="Times New Roman" panose="02020603050405020304" pitchFamily="18" charset="0"/>
-              <a:cs typeface="Times New Roman" panose="02020603050405020304" pitchFamily="18" charset="0"/>
-            </a:endParaRPr>
           </a:p>
           <a:p>
             <a:pPr marL="114300" indent="0">
               <a:buNone/>
             </a:pPr>
             <a:r>
-              <a:rPr lang="en-US" sz="1800" b="1" dirty="0" smtClean="0"/>
-              <a:t> </a:t>
-            </a:r>
-            <a:r>
               <a:rPr lang="en-US" sz="1800" b="1" dirty="0"/>
-              <a:t>General Concepts (Top):</a:t>
+              <a:t> General Concepts (Top):</a:t>
             </a:r>
           </a:p>
           <a:p>
@@ -13430,7 +13422,7 @@
               <a:tabLst/>
             </a:pPr>
             <a:r>
-              <a:rPr kumimoji="0" lang="en-US" sz="1800" b="1" i="0" u="none" strike="noStrike" cap="none" normalizeH="0" baseline="0" dirty="0" smtClean="0">
+              <a:rPr kumimoji="0" lang="en-US" sz="1800" b="1" i="0" u="none" strike="noStrike" cap="none" normalizeH="0" baseline="0" dirty="0">
                 <a:ln>
                   <a:noFill/>
                 </a:ln>
@@ -13462,7 +13454,7 @@
               <a:tabLst/>
             </a:pPr>
             <a:r>
-              <a:rPr kumimoji="0" lang="en-US" sz="1800" b="0" i="0" u="none" strike="noStrike" cap="none" normalizeH="0" baseline="0" dirty="0" smtClean="0">
+              <a:rPr kumimoji="0" lang="en-US" sz="1800" b="0" i="0" u="none" strike="noStrike" cap="none" normalizeH="0" baseline="0" dirty="0">
                 <a:ln>
                   <a:noFill/>
                 </a:ln>
@@ -13476,7 +13468,7 @@
               <a:t>Shows the </a:t>
             </a:r>
             <a:r>
-              <a:rPr kumimoji="0" lang="en-US" sz="1800" b="1" i="0" u="none" strike="noStrike" cap="none" normalizeH="0" baseline="0" dirty="0" smtClean="0">
+              <a:rPr kumimoji="0" lang="en-US" sz="1800" b="1" i="0" u="none" strike="noStrike" cap="none" normalizeH="0" baseline="0" dirty="0">
                 <a:ln>
                   <a:noFill/>
                 </a:ln>
@@ -13490,7 +13482,7 @@
               <a:t>state machine</a:t>
             </a:r>
             <a:r>
-              <a:rPr kumimoji="0" lang="en-US" sz="1800" b="0" i="0" u="none" strike="noStrike" cap="none" normalizeH="0" baseline="0" dirty="0" smtClean="0">
+              <a:rPr kumimoji="0" lang="en-US" sz="1800" b="0" i="0" u="none" strike="noStrike" cap="none" normalizeH="0" baseline="0" dirty="0">
                 <a:ln>
                   <a:noFill/>
                 </a:ln>
@@ -13504,7 +13496,7 @@
               <a:t> for toggling </a:t>
             </a:r>
             <a:r>
-              <a:rPr kumimoji="0" lang="en-US" sz="1800" b="1" i="0" u="none" strike="noStrike" cap="none" normalizeH="0" baseline="0" dirty="0" smtClean="0">
+              <a:rPr kumimoji="0" lang="en-US" sz="1800" b="1" i="0" u="none" strike="noStrike" cap="none" normalizeH="0" baseline="0" dirty="0">
                 <a:ln>
                   <a:noFill/>
                 </a:ln>
@@ -13518,7 +13510,7 @@
               <a:t>text style settings</a:t>
             </a:r>
             <a:r>
-              <a:rPr kumimoji="0" lang="en-US" sz="1800" b="0" i="0" u="none" strike="noStrike" cap="none" normalizeH="0" baseline="0" dirty="0" smtClean="0">
+              <a:rPr kumimoji="0" lang="en-US" sz="1800" b="0" i="0" u="none" strike="noStrike" cap="none" normalizeH="0" baseline="0" dirty="0">
                 <a:ln>
                   <a:noFill/>
                 </a:ln>
@@ -13550,7 +13542,7 @@
               <a:tabLst/>
             </a:pPr>
             <a:r>
-              <a:rPr kumimoji="0" lang="en-US" sz="1800" b="0" i="0" u="none" strike="noStrike" cap="none" normalizeH="0" baseline="0" dirty="0" smtClean="0">
+              <a:rPr kumimoji="0" lang="en-US" sz="1800" b="0" i="0" u="none" strike="noStrike" cap="none" normalizeH="0" baseline="0" dirty="0">
                 <a:ln>
                   <a:noFill/>
                 </a:ln>
@@ -13582,7 +13574,7 @@
               <a:tabLst/>
             </a:pPr>
             <a:r>
-              <a:rPr kumimoji="0" lang="en-US" sz="1800" b="0" i="0" u="none" strike="noStrike" cap="none" normalizeH="0" baseline="0" dirty="0" smtClean="0">
+              <a:rPr kumimoji="0" lang="en-US" sz="1800" b="0" i="0" u="none" strike="noStrike" cap="none" normalizeH="0" baseline="0" dirty="0">
                 <a:ln>
                   <a:noFill/>
                 </a:ln>
@@ -13614,7 +13606,7 @@
               <a:tabLst/>
             </a:pPr>
             <a:r>
-              <a:rPr kumimoji="0" lang="en-US" sz="1800" b="0" i="0" u="none" strike="noStrike" cap="none" normalizeH="0" baseline="0" dirty="0" smtClean="0">
+              <a:rPr kumimoji="0" lang="en-US" sz="1800" b="0" i="0" u="none" strike="noStrike" cap="none" normalizeH="0" baseline="0" dirty="0">
                 <a:ln>
                   <a:noFill/>
                 </a:ln>
@@ -13646,7 +13638,7 @@
               <a:tabLst/>
             </a:pPr>
             <a:r>
-              <a:rPr kumimoji="0" lang="en-US" sz="1800" b="0" i="0" u="none" strike="noStrike" cap="none" normalizeH="0" baseline="0" dirty="0" smtClean="0">
+              <a:rPr kumimoji="0" lang="en-US" sz="1800" b="0" i="0" u="none" strike="noStrike" cap="none" normalizeH="0" baseline="0" dirty="0">
                 <a:ln>
                   <a:noFill/>
                 </a:ln>
@@ -13678,7 +13670,7 @@
               <a:tabLst/>
             </a:pPr>
             <a:r>
-              <a:rPr kumimoji="0" lang="en-US" sz="1800" b="0" i="0" u="none" strike="noStrike" cap="none" normalizeH="0" baseline="0" dirty="0" smtClean="0">
+              <a:rPr kumimoji="0" lang="en-US" sz="1800" b="0" i="0" u="none" strike="noStrike" cap="none" normalizeH="0" baseline="0" dirty="0">
                 <a:ln>
                   <a:noFill/>
                 </a:ln>
@@ -13710,7 +13702,7 @@
               <a:tabLst/>
             </a:pPr>
             <a:r>
-              <a:rPr kumimoji="0" lang="en-US" sz="1800" b="0" i="0" u="none" strike="noStrike" cap="none" normalizeH="0" baseline="0" dirty="0" smtClean="0">
+              <a:rPr kumimoji="0" lang="en-US" sz="1800" b="0" i="0" u="none" strike="noStrike" cap="none" normalizeH="0" baseline="0" dirty="0">
                 <a:ln>
                   <a:noFill/>
                 </a:ln>
@@ -13724,7 +13716,7 @@
               <a:t>Transitions: Occur on clicking </a:t>
             </a:r>
             <a:r>
-              <a:rPr kumimoji="0" lang="en-US" sz="1800" b="1" i="0" u="none" strike="noStrike" cap="none" normalizeH="0" baseline="0" dirty="0" smtClean="0">
+              <a:rPr kumimoji="0" lang="en-US" sz="1800" b="1" i="0" u="none" strike="noStrike" cap="none" normalizeH="0" baseline="0" dirty="0">
                 <a:ln>
                   <a:noFill/>
                 </a:ln>
@@ -13738,7 +13730,7 @@
               <a:t>'bold'</a:t>
             </a:r>
             <a:r>
-              <a:rPr kumimoji="0" lang="en-US" sz="1800" b="0" i="0" u="none" strike="noStrike" cap="none" normalizeH="0" baseline="0" dirty="0" smtClean="0">
+              <a:rPr kumimoji="0" lang="en-US" sz="1800" b="0" i="0" u="none" strike="noStrike" cap="none" normalizeH="0" baseline="0" dirty="0">
                 <a:ln>
                   <a:noFill/>
                 </a:ln>
@@ -13752,7 +13744,7 @@
               <a:t> or </a:t>
             </a:r>
             <a:r>
-              <a:rPr kumimoji="0" lang="en-US" sz="1800" b="1" i="0" u="none" strike="noStrike" cap="none" normalizeH="0" baseline="0" dirty="0" smtClean="0">
+              <a:rPr kumimoji="0" lang="en-US" sz="1800" b="1" i="0" u="none" strike="noStrike" cap="none" normalizeH="0" baseline="0" dirty="0">
                 <a:ln>
                   <a:noFill/>
                 </a:ln>
@@ -13766,7 +13758,7 @@
               <a:t>'italic'</a:t>
             </a:r>
             <a:r>
-              <a:rPr kumimoji="0" lang="en-US" sz="1800" b="0" i="0" u="none" strike="noStrike" cap="none" normalizeH="0" baseline="0" dirty="0" smtClean="0">
+              <a:rPr kumimoji="0" lang="en-US" sz="1800" b="0" i="0" u="none" strike="noStrike" cap="none" normalizeH="0" baseline="0" dirty="0">
                 <a:ln>
                   <a:noFill/>
                 </a:ln>
@@ -13797,7 +13789,7 @@
               <a:buNone/>
               <a:tabLst/>
             </a:pPr>
-            <a:endParaRPr kumimoji="0" lang="en-US" sz="1800" b="0" i="0" u="none" strike="noStrike" cap="none" normalizeH="0" baseline="0" dirty="0" smtClean="0">
+            <a:endParaRPr kumimoji="0" lang="en-US" sz="1800" b="0" i="0" u="none" strike="noStrike" cap="none" normalizeH="0" baseline="0" dirty="0">
               <a:ln>
                 <a:noFill/>
               </a:ln>
@@ -13896,7 +13888,7 @@
               <a:t>Diagrammatic notations: </a:t>
             </a:r>
             <a:r>
-              <a:rPr lang="en-US" dirty="0" err="1">
+              <a:rPr lang="en-US" dirty="0">
                 <a:solidFill>
                   <a:srgbClr val="FF0000"/>
                 </a:solidFill>
@@ -13905,7 +13897,7 @@
                 <a:cs typeface="Times New Roman"/>
                 <a:sym typeface="Times New Roman"/>
               </a:rPr>
-              <a:t>Petrinets</a:t>
+              <a:t>Petri nets</a:t>
             </a:r>
             <a:endParaRPr dirty="0"/>
           </a:p>
@@ -14068,6 +14060,9 @@
             </a:pPr>
             <a:r>
               <a:rPr lang="en-US" sz="1800" dirty="0">
+                <a:highlight>
+                  <a:srgbClr val="FFFF00"/>
+                </a:highlight>
                 <a:latin typeface="Times New Roman"/>
                 <a:ea typeface="Times New Roman"/>
                 <a:cs typeface="Times New Roman"/>
@@ -14080,6 +14075,9 @@
                 <a:solidFill>
                   <a:schemeClr val="hlink"/>
                 </a:solidFill>
+                <a:highlight>
+                  <a:srgbClr val="FFFF00"/>
+                </a:highlight>
                 <a:latin typeface="Times New Roman"/>
                 <a:ea typeface="Times New Roman"/>
                 <a:cs typeface="Times New Roman"/>
@@ -14090,6 +14088,9 @@
             </a:r>
             <a:r>
               <a:rPr lang="en-US" sz="1800" dirty="0">
+                <a:highlight>
+                  <a:srgbClr val="FFFF00"/>
+                </a:highlight>
                 <a:latin typeface="Times New Roman"/>
                 <a:ea typeface="Times New Roman"/>
                 <a:cs typeface="Times New Roman"/>
@@ -14098,6 +14099,9 @@
               <a:t> that has two types of elements: places and transitions. </a:t>
             </a:r>
             <a:endParaRPr sz="1800" dirty="0">
+              <a:highlight>
+                <a:srgbClr val="FFFF00"/>
+              </a:highlight>
               <a:latin typeface="Times New Roman"/>
               <a:ea typeface="Times New Roman"/>
               <a:cs typeface="Times New Roman"/>
@@ -14336,18 +14340,11 @@
               <a:buNone/>
             </a:pPr>
             <a:r>
-              <a:rPr lang="en-US" sz="2300" b="1" dirty="0" smtClean="0">
-                <a:latin typeface="Times New Roman" panose="02020603050405020304" pitchFamily="18" charset="0"/>
-                <a:cs typeface="Times New Roman" panose="02020603050405020304" pitchFamily="18" charset="0"/>
-              </a:rPr>
-              <a:t>Petri </a:t>
-            </a:r>
-            <a:r>
               <a:rPr lang="en-US" sz="2300" b="1" dirty="0">
                 <a:latin typeface="Times New Roman" panose="02020603050405020304" pitchFamily="18" charset="0"/>
                 <a:cs typeface="Times New Roman" panose="02020603050405020304" pitchFamily="18" charset="0"/>
               </a:rPr>
-              <a:t>Nets - Core Concepts</a:t>
+              <a:t>Petri Nets - Core Concepts</a:t>
             </a:r>
           </a:p>
           <a:p>
@@ -14520,18 +14517,11 @@
               <a:buNone/>
             </a:pPr>
             <a:r>
-              <a:rPr lang="en-US" sz="2300" b="1" dirty="0" smtClean="0">
-                <a:latin typeface="Times New Roman" panose="02020603050405020304" pitchFamily="18" charset="0"/>
-                <a:cs typeface="Times New Roman" panose="02020603050405020304" pitchFamily="18" charset="0"/>
-              </a:rPr>
-              <a:t>Behavioral </a:t>
-            </a:r>
-            <a:r>
               <a:rPr lang="en-US" sz="2300" b="1" dirty="0">
                 <a:latin typeface="Times New Roman" panose="02020603050405020304" pitchFamily="18" charset="0"/>
                 <a:cs typeface="Times New Roman" panose="02020603050405020304" pitchFamily="18" charset="0"/>
               </a:rPr>
-              <a:t>Rules</a:t>
+              <a:t>Behavioral Rules</a:t>
             </a:r>
           </a:p>
           <a:p>
@@ -15468,19 +15458,8 @@
                 <a:latin typeface="Times New Roman" panose="02020603050405020304" pitchFamily="18" charset="0"/>
                 <a:cs typeface="Times New Roman" panose="02020603050405020304" pitchFamily="18" charset="0"/>
               </a:rPr>
-              <a:t>Dispensing the coffee</a:t>
-            </a:r>
-            <a:r>
-              <a:rPr lang="en-US" dirty="0" smtClean="0">
-                <a:latin typeface="Times New Roman" panose="02020603050405020304" pitchFamily="18" charset="0"/>
-                <a:cs typeface="Times New Roman" panose="02020603050405020304" pitchFamily="18" charset="0"/>
-              </a:rPr>
-              <a:t>.  </a:t>
-            </a:r>
-            <a:endParaRPr lang="en-US" dirty="0">
-              <a:latin typeface="Times New Roman" panose="02020603050405020304" pitchFamily="18" charset="0"/>
-              <a:cs typeface="Times New Roman" panose="02020603050405020304" pitchFamily="18" charset="0"/>
-            </a:endParaRPr>
+              <a:t>Dispensing the coffee.  </a:t>
+            </a:r>
           </a:p>
           <a:p>
             <a:pPr marL="114300" indent="0">
@@ -15960,7 +15939,7 @@
               <a:tabLst/>
             </a:pPr>
             <a:r>
-              <a:rPr kumimoji="0" lang="en-US" sz="1600" b="1" i="0" u="none" strike="noStrike" cap="none" normalizeH="0" baseline="0" dirty="0" smtClean="0">
+              <a:rPr kumimoji="0" lang="en-US" sz="1600" b="1" i="0" u="none" strike="noStrike" cap="none" normalizeH="0" baseline="0" dirty="0">
                 <a:ln>
                   <a:noFill/>
                 </a:ln>
@@ -15992,7 +15971,7 @@
               <a:tabLst/>
             </a:pPr>
             <a:r>
-              <a:rPr kumimoji="0" lang="en-US" sz="1600" b="1" i="0" u="none" strike="noStrike" cap="none" normalizeH="0" baseline="0" dirty="0" smtClean="0">
+              <a:rPr kumimoji="0" lang="en-US" sz="1600" b="1" i="0" u="none" strike="noStrike" cap="none" normalizeH="0" baseline="0" dirty="0">
                 <a:ln>
                   <a:noFill/>
                 </a:ln>
@@ -16024,7 +16003,7 @@
               <a:tabLst/>
             </a:pPr>
             <a:r>
-              <a:rPr kumimoji="0" lang="en-US" sz="1600" b="0" i="0" u="none" strike="noStrike" cap="none" normalizeH="0" baseline="0" dirty="0" smtClean="0">
+              <a:rPr kumimoji="0" lang="en-US" sz="1600" b="0" i="0" u="none" strike="noStrike" cap="none" normalizeH="0" baseline="0" dirty="0">
                 <a:ln>
                   <a:noFill/>
                 </a:ln>
@@ -16056,7 +16035,7 @@
               <a:tabLst/>
             </a:pPr>
             <a:r>
-              <a:rPr kumimoji="0" lang="en-US" sz="1600" b="0" i="0" u="none" strike="noStrike" cap="none" normalizeH="0" baseline="0" dirty="0" smtClean="0">
+              <a:rPr kumimoji="0" lang="en-US" sz="1600" b="0" i="0" u="none" strike="noStrike" cap="none" normalizeH="0" baseline="0" dirty="0">
                 <a:ln>
                   <a:noFill/>
                 </a:ln>
@@ -16088,7 +16067,7 @@
               <a:tabLst/>
             </a:pPr>
             <a:r>
-              <a:rPr kumimoji="0" lang="en-US" sz="1600" b="0" i="0" u="none" strike="noStrike" cap="none" normalizeH="0" baseline="0" dirty="0" smtClean="0">
+              <a:rPr kumimoji="0" lang="en-US" sz="1600" b="0" i="0" u="none" strike="noStrike" cap="none" normalizeH="0" baseline="0" dirty="0">
                 <a:ln>
                   <a:noFill/>
                 </a:ln>
@@ -16120,7 +16099,7 @@
               <a:tabLst/>
             </a:pPr>
             <a:r>
-              <a:rPr kumimoji="0" lang="en-US" sz="1600" b="0" i="0" u="none" strike="noStrike" cap="none" normalizeH="0" baseline="0" dirty="0" smtClean="0">
+              <a:rPr kumimoji="0" lang="en-US" sz="1600" b="0" i="0" u="none" strike="noStrike" cap="none" normalizeH="0" baseline="0" dirty="0">
                 <a:ln>
                   <a:noFill/>
                 </a:ln>
@@ -16152,7 +16131,7 @@
               <a:tabLst/>
             </a:pPr>
             <a:r>
-              <a:rPr kumimoji="0" lang="en-US" sz="1600" b="1" i="0" u="none" strike="noStrike" cap="none" normalizeH="0" baseline="0" dirty="0" smtClean="0">
+              <a:rPr kumimoji="0" lang="en-US" sz="1600" b="1" i="0" u="none" strike="noStrike" cap="none" normalizeH="0" baseline="0" dirty="0">
                 <a:ln>
                   <a:noFill/>
                 </a:ln>
@@ -16184,7 +16163,7 @@
               <a:tabLst/>
             </a:pPr>
             <a:r>
-              <a:rPr kumimoji="0" lang="en-US" sz="1600" b="0" i="0" u="none" strike="noStrike" cap="none" normalizeH="0" baseline="0" dirty="0" smtClean="0">
+              <a:rPr kumimoji="0" lang="en-US" sz="1600" b="0" i="0" u="none" strike="noStrike" cap="none" normalizeH="0" baseline="0" dirty="0">
                 <a:ln>
                   <a:noFill/>
                 </a:ln>
@@ -16216,7 +16195,7 @@
               <a:tabLst/>
             </a:pPr>
             <a:r>
-              <a:rPr kumimoji="0" lang="en-US" sz="1600" b="0" i="0" u="none" strike="noStrike" cap="none" normalizeH="0" baseline="0" dirty="0" smtClean="0">
+              <a:rPr kumimoji="0" lang="en-US" sz="1600" b="0" i="0" u="none" strike="noStrike" cap="none" normalizeH="0" baseline="0" dirty="0">
                 <a:ln>
                   <a:noFill/>
                 </a:ln>
@@ -16248,7 +16227,7 @@
               <a:tabLst/>
             </a:pPr>
             <a:r>
-              <a:rPr kumimoji="0" lang="en-US" sz="1600" b="0" i="0" u="none" strike="noStrike" cap="none" normalizeH="0" baseline="0" dirty="0" smtClean="0">
+              <a:rPr kumimoji="0" lang="en-US" sz="1600" b="0" i="0" u="none" strike="noStrike" cap="none" normalizeH="0" baseline="0" dirty="0">
                 <a:ln>
                   <a:noFill/>
                 </a:ln>
@@ -16280,7 +16259,7 @@
               <a:tabLst/>
             </a:pPr>
             <a:r>
-              <a:rPr kumimoji="0" lang="en-US" sz="1600" b="0" i="0" u="none" strike="noStrike" cap="none" normalizeH="0" baseline="0" dirty="0" smtClean="0">
+              <a:rPr kumimoji="0" lang="en-US" sz="1600" b="0" i="0" u="none" strike="noStrike" cap="none" normalizeH="0" baseline="0" dirty="0">
                 <a:ln>
                   <a:noFill/>
                 </a:ln>
@@ -16311,18 +16290,11 @@
               <a:tabLst/>
             </a:pPr>
             <a:r>
-              <a:rPr lang="en-US" sz="1600" b="1" dirty="0" smtClean="0">
-                <a:latin typeface="Times New Roman" panose="02020603050405020304" pitchFamily="18" charset="0"/>
-                <a:cs typeface="Times New Roman" panose="02020603050405020304" pitchFamily="18" charset="0"/>
-              </a:rPr>
-              <a:t>Flow </a:t>
-            </a:r>
-            <a:r>
               <a:rPr lang="en-US" sz="1600" b="1" dirty="0">
                 <a:latin typeface="Times New Roman" panose="02020603050405020304" pitchFamily="18" charset="0"/>
                 <a:cs typeface="Times New Roman" panose="02020603050405020304" pitchFamily="18" charset="0"/>
               </a:rPr>
-              <a:t>(Token Movement Logic)</a:t>
+              <a:t>Flow (Token Movement Logic)</a:t>
             </a:r>
           </a:p>
           <a:p>
@@ -16508,7 +16480,7 @@
               <a:buNone/>
               <a:tabLst/>
             </a:pPr>
-            <a:endParaRPr kumimoji="0" lang="en-US" sz="1800" b="0" i="0" u="none" strike="noStrike" cap="none" normalizeH="0" baseline="0" dirty="0" smtClean="0">
+            <a:endParaRPr kumimoji="0" lang="en-US" sz="1800" b="0" i="0" u="none" strike="noStrike" cap="none" normalizeH="0" baseline="0" dirty="0">
               <a:ln>
                 <a:noFill/>
               </a:ln>
@@ -17259,8 +17231,20 @@
             <a:tbl>
               <a:tblPr/>
               <a:tblGrid>
-                <a:gridCol w="3165657"/>
-                <a:gridCol w="3165657"/>
+                <a:gridCol w="3165657">
+                  <a:extLst>
+                    <a:ext uri="{9D8B030D-6E8A-4147-A177-3AD203B41FA5}">
+                      <a16:colId xmlns:a16="http://schemas.microsoft.com/office/drawing/2014/main" val="20000"/>
+                    </a:ext>
+                  </a:extLst>
+                </a:gridCol>
+                <a:gridCol w="3165657">
+                  <a:extLst>
+                    <a:ext uri="{9D8B030D-6E8A-4147-A177-3AD203B41FA5}">
+                      <a16:colId xmlns:a16="http://schemas.microsoft.com/office/drawing/2014/main" val="20001"/>
+                    </a:ext>
+                  </a:extLst>
+                </a:gridCol>
               </a:tblGrid>
               <a:tr h="0">
                 <a:tc>
@@ -17315,6 +17299,11 @@
                     </a:lnB>
                   </a:tcPr>
                 </a:tc>
+                <a:extLst>
+                  <a:ext uri="{0D108BD9-81ED-4DB2-BD59-A6C34878D82A}">
+                    <a16:rowId xmlns:a16="http://schemas.microsoft.com/office/drawing/2014/main" val="10000"/>
+                  </a:ext>
+                </a:extLst>
               </a:tr>
               <a:tr h="0">
                 <a:tc>
@@ -17370,6 +17359,11 @@
                     </a:lnB>
                   </a:tcPr>
                 </a:tc>
+                <a:extLst>
+                  <a:ext uri="{0D108BD9-81ED-4DB2-BD59-A6C34878D82A}">
+                    <a16:rowId xmlns:a16="http://schemas.microsoft.com/office/drawing/2014/main" val="10001"/>
+                  </a:ext>
+                </a:extLst>
               </a:tr>
               <a:tr h="0">
                 <a:tc>
@@ -17433,6 +17427,11 @@
                     </a:lnB>
                   </a:tcPr>
                 </a:tc>
+                <a:extLst>
+                  <a:ext uri="{0D108BD9-81ED-4DB2-BD59-A6C34878D82A}">
+                    <a16:rowId xmlns:a16="http://schemas.microsoft.com/office/drawing/2014/main" val="10002"/>
+                  </a:ext>
+                </a:extLst>
               </a:tr>
               <a:tr h="0">
                 <a:tc>
@@ -17496,6 +17495,11 @@
                     </a:lnB>
                   </a:tcPr>
                 </a:tc>
+                <a:extLst>
+                  <a:ext uri="{0D108BD9-81ED-4DB2-BD59-A6C34878D82A}">
+                    <a16:rowId xmlns:a16="http://schemas.microsoft.com/office/drawing/2014/main" val="10003"/>
+                  </a:ext>
+                </a:extLst>
               </a:tr>
             </a:tbl>
           </a:graphicData>
@@ -17577,7 +17581,7 @@
               <a:tabLst/>
             </a:pPr>
             <a:r>
-              <a:rPr kumimoji="0" lang="en-US" sz="2000" b="1" i="0" u="none" strike="noStrike" cap="none" normalizeH="0" baseline="0" dirty="0" smtClean="0">
+              <a:rPr kumimoji="0" lang="en-US" sz="2000" b="1" i="0" u="none" strike="noStrike" cap="none" normalizeH="0" baseline="0" dirty="0">
                 <a:ln>
                   <a:noFill/>
                 </a:ln>
@@ -17608,7 +17612,7 @@
               <a:buNone/>
               <a:tabLst/>
             </a:pPr>
-            <a:endParaRPr kumimoji="0" lang="en-US" sz="1800" b="0" i="0" u="none" strike="noStrike" cap="none" normalizeH="0" baseline="0" dirty="0" smtClean="0">
+            <a:endParaRPr kumimoji="0" lang="en-US" sz="1800" b="0" i="0" u="none" strike="noStrike" cap="none" normalizeH="0" baseline="0" dirty="0">
               <a:ln>
                 <a:noFill/>
               </a:ln>
@@ -17804,28 +17808,17 @@
                 <a:latin typeface="Times New Roman" panose="02020603050405020304" pitchFamily="18" charset="0"/>
                 <a:cs typeface="Times New Roman" panose="02020603050405020304" pitchFamily="18" charset="0"/>
               </a:rPr>
-              <a:t>: Adding or modifying behaviors often means touching only one small sub‑machine rather than reworking a huge flat FSM</a:t>
-            </a:r>
-            <a:r>
-              <a:rPr lang="en-US" sz="2000" dirty="0" smtClean="0">
-                <a:latin typeface="Times New Roman" panose="02020603050405020304" pitchFamily="18" charset="0"/>
-                <a:cs typeface="Times New Roman" panose="02020603050405020304" pitchFamily="18" charset="0"/>
-              </a:rPr>
-              <a:t>.</a:t>
-            </a:r>
-          </a:p>
-          <a:p>
-            <a:r>
-              <a:rPr lang="en-US" sz="2000" dirty="0" smtClean="0">
+              <a:t>: Adding or modifying behaviors often means touching only one small sub‑machine rather than reworking a huge flat FSM.</a:t>
+            </a:r>
+          </a:p>
+          <a:p>
+            <a:r>
+              <a:rPr lang="en-US" sz="2000" dirty="0">
                 <a:latin typeface="Times New Roman" panose="02020603050405020304" pitchFamily="18" charset="0"/>
                 <a:cs typeface="Times New Roman" panose="02020603050405020304" pitchFamily="18" charset="0"/>
               </a:rPr>
               <a:t>Example:</a:t>
             </a:r>
-            <a:endParaRPr lang="en-US" sz="2000" dirty="0">
-              <a:latin typeface="Times New Roman" panose="02020603050405020304" pitchFamily="18" charset="0"/>
-              <a:cs typeface="Times New Roman" panose="02020603050405020304" pitchFamily="18" charset="0"/>
-            </a:endParaRPr>
           </a:p>
         </p:txBody>
       </p:sp>
@@ -17950,14 +17943,7 @@
                 <a:latin typeface="Times New Roman" panose="02020603050405020304" pitchFamily="18" charset="0"/>
                 <a:cs typeface="Times New Roman" panose="02020603050405020304" pitchFamily="18" charset="0"/>
               </a:rPr>
-              <a:t> is modeling—a simple “sign‑up/login” flow with an asynchronous submission step, plus an inner composite state for the post‑submit pages</a:t>
-            </a:r>
-            <a:r>
-              <a:rPr lang="en-US" sz="2000" dirty="0" smtClean="0">
-                <a:latin typeface="Times New Roman" panose="02020603050405020304" pitchFamily="18" charset="0"/>
-                <a:cs typeface="Times New Roman" panose="02020603050405020304" pitchFamily="18" charset="0"/>
-              </a:rPr>
-              <a:t>:</a:t>
+              <a:t> is modeling—a simple “sign‑up/login” flow with an asynchronous submission step, plus an inner composite state for the post‑submit pages:</a:t>
             </a:r>
           </a:p>
           <a:p>
@@ -18688,7 +18674,7 @@
               <a:tabLst/>
             </a:pPr>
             <a:r>
-              <a:rPr kumimoji="0" lang="en-US" sz="2000" b="1" i="0" u="none" strike="noStrike" cap="none" normalizeH="0" baseline="0" dirty="0" smtClean="0">
+              <a:rPr kumimoji="0" lang="en-US" sz="2000" b="1" i="0" u="none" strike="noStrike" cap="none" normalizeH="0" baseline="0" dirty="0">
                 <a:ln>
                   <a:noFill/>
                 </a:ln>
@@ -18701,7 +18687,7 @@
               </a:rPr>
               <a:t>Error page → Empty form</a:t>
             </a:r>
-            <a:endParaRPr kumimoji="0" lang="en-US" sz="2000" b="0" i="0" u="none" strike="noStrike" cap="none" normalizeH="0" baseline="0" dirty="0" smtClean="0">
+            <a:endParaRPr kumimoji="0" lang="en-US" sz="2000" b="0" i="0" u="none" strike="noStrike" cap="none" normalizeH="0" baseline="0" dirty="0">
               <a:ln>
                 <a:noFill/>
               </a:ln>
@@ -18731,7 +18717,7 @@
               <a:tabLst/>
             </a:pPr>
             <a:r>
-              <a:rPr kumimoji="0" lang="en-US" sz="2000" b="0" i="0" u="none" strike="noStrike" cap="none" normalizeH="0" baseline="0" dirty="0" smtClean="0">
+              <a:rPr kumimoji="0" lang="en-US" sz="2000" b="0" i="0" u="none" strike="noStrike" cap="none" normalizeH="0" baseline="0" dirty="0">
                 <a:ln>
                   <a:noFill/>
                 </a:ln>
@@ -18745,7 +18731,7 @@
               <a:t>Labeled </a:t>
             </a:r>
             <a:r>
-              <a:rPr kumimoji="0" lang="en-US" sz="2000" b="1" i="0" u="none" strike="noStrike" cap="none" normalizeH="0" baseline="0" dirty="0" smtClean="0">
+              <a:rPr kumimoji="0" lang="en-US" sz="2000" b="1" i="0" u="none" strike="noStrike" cap="none" normalizeH="0" baseline="0" dirty="0">
                 <a:ln>
                   <a:noFill/>
                 </a:ln>
@@ -18758,7 +18744,7 @@
               </a:rPr>
               <a:t>REGISTER</a:t>
             </a:r>
-            <a:endParaRPr kumimoji="0" lang="en-US" sz="2000" b="0" i="0" u="none" strike="noStrike" cap="none" normalizeH="0" baseline="0" dirty="0" smtClean="0">
+            <a:endParaRPr kumimoji="0" lang="en-US" sz="2000" b="0" i="0" u="none" strike="noStrike" cap="none" normalizeH="0" baseline="0" dirty="0">
               <a:ln>
                 <a:noFill/>
               </a:ln>
@@ -18788,7 +18774,7 @@
               <a:tabLst/>
             </a:pPr>
             <a:r>
-              <a:rPr kumimoji="0" lang="en-US" sz="2000" b="0" i="0" u="none" strike="noStrike" cap="none" normalizeH="0" baseline="0" dirty="0" smtClean="0">
+              <a:rPr kumimoji="0" lang="en-US" sz="2000" b="0" i="0" u="none" strike="noStrike" cap="none" normalizeH="0" baseline="0" dirty="0">
                 <a:ln>
                   <a:noFill/>
                 </a:ln>
@@ -18819,7 +18805,7 @@
               <a:tabLst/>
             </a:pPr>
             <a:r>
-              <a:rPr kumimoji="0" lang="en-US" sz="2000" b="1" i="0" u="none" strike="noStrike" cap="none" normalizeH="0" baseline="0" dirty="0" smtClean="0">
+              <a:rPr kumimoji="0" lang="en-US" sz="2000" b="1" i="0" u="none" strike="noStrike" cap="none" normalizeH="0" baseline="0" dirty="0">
                 <a:ln>
                   <a:noFill/>
                 </a:ln>
@@ -18832,7 +18818,7 @@
               </a:rPr>
               <a:t>Welcome page → Login page</a:t>
             </a:r>
-            <a:endParaRPr kumimoji="0" lang="en-US" sz="2000" b="0" i="0" u="none" strike="noStrike" cap="none" normalizeH="0" baseline="0" dirty="0" smtClean="0">
+            <a:endParaRPr kumimoji="0" lang="en-US" sz="2000" b="0" i="0" u="none" strike="noStrike" cap="none" normalizeH="0" baseline="0" dirty="0">
               <a:ln>
                 <a:noFill/>
               </a:ln>
@@ -18862,7 +18848,7 @@
               <a:tabLst/>
             </a:pPr>
             <a:r>
-              <a:rPr kumimoji="0" lang="en-US" sz="2000" b="0" i="0" u="none" strike="noStrike" cap="none" normalizeH="0" baseline="0" dirty="0" smtClean="0">
+              <a:rPr kumimoji="0" lang="en-US" sz="2000" b="0" i="0" u="none" strike="noStrike" cap="none" normalizeH="0" baseline="0" dirty="0">
                 <a:ln>
                   <a:noFill/>
                 </a:ln>
@@ -18876,7 +18862,7 @@
               <a:t>Labeled </a:t>
             </a:r>
             <a:r>
-              <a:rPr kumimoji="0" lang="en-US" sz="2000" b="1" i="0" u="none" strike="noStrike" cap="none" normalizeH="0" baseline="0" dirty="0" smtClean="0">
+              <a:rPr kumimoji="0" lang="en-US" sz="2000" b="1" i="0" u="none" strike="noStrike" cap="none" normalizeH="0" baseline="0" dirty="0">
                 <a:ln>
                   <a:noFill/>
                 </a:ln>
@@ -18889,7 +18875,7 @@
               </a:rPr>
               <a:t>LOGOUT</a:t>
             </a:r>
-            <a:endParaRPr kumimoji="0" lang="en-US" sz="2000" b="0" i="0" u="none" strike="noStrike" cap="none" normalizeH="0" baseline="0" dirty="0" smtClean="0">
+            <a:endParaRPr kumimoji="0" lang="en-US" sz="2000" b="0" i="0" u="none" strike="noStrike" cap="none" normalizeH="0" baseline="0" dirty="0">
               <a:ln>
                 <a:noFill/>
               </a:ln>
@@ -18919,7 +18905,7 @@
               <a:tabLst/>
             </a:pPr>
             <a:r>
-              <a:rPr kumimoji="0" lang="en-US" sz="2000" b="0" i="0" u="none" strike="noStrike" cap="none" normalizeH="0" baseline="0" dirty="0" smtClean="0">
+              <a:rPr kumimoji="0" lang="en-US" sz="2000" b="0" i="0" u="none" strike="noStrike" cap="none" normalizeH="0" baseline="0" dirty="0">
                 <a:ln>
                   <a:noFill/>
                 </a:ln>
@@ -18932,7 +18918,7 @@
               </a:rPr>
               <a:t>Once you’re “logged in” (on the welcome screen) you can log out, which takes you to a login screen inside the same composite.</a:t>
             </a:r>
-            <a:endParaRPr kumimoji="0" lang="en-US" sz="1800" b="0" i="0" u="none" strike="noStrike" cap="none" normalizeH="0" baseline="0" dirty="0" smtClean="0">
+            <a:endParaRPr kumimoji="0" lang="en-US" sz="1800" b="0" i="0" u="none" strike="noStrike" cap="none" normalizeH="0" baseline="0" dirty="0">
               <a:ln>
                 <a:noFill/>
               </a:ln>
@@ -18985,7 +18971,7 @@
               <a:buNone/>
               <a:tabLst/>
             </a:pPr>
-            <a:endParaRPr kumimoji="0" lang="en-US" sz="1800" b="0" i="0" u="none" strike="noStrike" cap="none" normalizeH="0" baseline="0" dirty="0" smtClean="0">
+            <a:endParaRPr kumimoji="0" lang="en-US" sz="1800" b="0" i="0" u="none" strike="noStrike" cap="none" normalizeH="0" baseline="0" dirty="0">
               <a:ln>
                 <a:noFill/>
               </a:ln>
@@ -19543,22 +19529,13 @@
               <a:buNone/>
             </a:pPr>
             <a:r>
-              <a:rPr lang="en-US" dirty="0" smtClean="0">
-                <a:latin typeface="Times New Roman"/>
-                <a:ea typeface="Times New Roman"/>
-                <a:cs typeface="Times New Roman"/>
-                <a:sym typeface="Times New Roman"/>
-              </a:rPr>
-              <a:t> </a:t>
-            </a:r>
-            <a:r>
               <a:rPr lang="en-US" dirty="0">
                 <a:latin typeface="Times New Roman"/>
                 <a:ea typeface="Times New Roman"/>
                 <a:cs typeface="Times New Roman"/>
                 <a:sym typeface="Times New Roman"/>
               </a:rPr>
-              <a:t>Dialog Design Notations</a:t>
+              <a:t> Dialog Design Notations</a:t>
             </a:r>
             <a:endParaRPr dirty="0"/>
           </a:p>
@@ -20766,13 +20743,6 @@
               </a:rPr>
               <a:t>Purpose:</a:t>
             </a:r>
-            <a:r>
-              <a:rPr lang="en-US" sz="2000" dirty="0">
-                <a:latin typeface="Times New Roman" panose="02020603050405020304" pitchFamily="18" charset="0"/>
-                <a:cs typeface="Times New Roman" panose="02020603050405020304" pitchFamily="18" charset="0"/>
-              </a:rPr>
-              <a:t/>
-            </a:r>
             <a:br>
               <a:rPr lang="en-US" sz="2000" dirty="0">
                 <a:latin typeface="Times New Roman" panose="02020603050405020304" pitchFamily="18" charset="0"/>
@@ -20819,14 +20789,7 @@
                 <a:latin typeface="Times New Roman" panose="02020603050405020304" pitchFamily="18" charset="0"/>
                 <a:cs typeface="Times New Roman" panose="02020603050405020304" pitchFamily="18" charset="0"/>
               </a:rPr>
-              <a:t>System Design (esp. for data-driven systems</a:t>
-            </a:r>
-            <a:r>
-              <a:rPr lang="en-US" sz="2000" b="1" dirty="0" smtClean="0">
-                <a:latin typeface="Times New Roman" panose="02020603050405020304" pitchFamily="18" charset="0"/>
-                <a:cs typeface="Times New Roman" panose="02020603050405020304" pitchFamily="18" charset="0"/>
-              </a:rPr>
-              <a:t>)</a:t>
+              <a:t>System Design (esp. for data-driven systems)</a:t>
             </a:r>
           </a:p>
           <a:p>
@@ -20838,14 +20801,7 @@
                 <a:latin typeface="Times New Roman" panose="02020603050405020304" pitchFamily="18" charset="0"/>
                 <a:cs typeface="Times New Roman" panose="02020603050405020304" pitchFamily="18" charset="0"/>
               </a:rPr>
-              <a:t>Key Features</a:t>
-            </a:r>
-            <a:r>
-              <a:rPr lang="en-US" sz="2000" b="1" dirty="0" smtClean="0">
-                <a:latin typeface="Times New Roman" panose="02020603050405020304" pitchFamily="18" charset="0"/>
-                <a:cs typeface="Times New Roman" panose="02020603050405020304" pitchFamily="18" charset="0"/>
-              </a:rPr>
-              <a:t>: </a:t>
+              <a:t>Key Features: </a:t>
             </a:r>
           </a:p>
           <a:p>
@@ -20853,32 +20809,18 @@
               <a:buNone/>
             </a:pPr>
             <a:r>
-              <a:rPr lang="en-US" sz="2000" b="1" dirty="0" smtClean="0">
-                <a:latin typeface="Times New Roman" panose="02020603050405020304" pitchFamily="18" charset="0"/>
-                <a:cs typeface="Times New Roman" panose="02020603050405020304" pitchFamily="18" charset="0"/>
-              </a:rPr>
-              <a:t>Clarity</a:t>
-            </a:r>
-            <a:r>
               <a:rPr lang="en-US" sz="2000" b="1" dirty="0">
                 <a:latin typeface="Times New Roman" panose="02020603050405020304" pitchFamily="18" charset="0"/>
                 <a:cs typeface="Times New Roman" panose="02020603050405020304" pitchFamily="18" charset="0"/>
               </a:rPr>
-              <a:t>: </a:t>
+              <a:t>Clarity: </a:t>
             </a:r>
             <a:r>
               <a:rPr lang="en-US" sz="2000" dirty="0">
                 <a:latin typeface="Times New Roman" panose="02020603050405020304" pitchFamily="18" charset="0"/>
                 <a:cs typeface="Times New Roman" panose="02020603050405020304" pitchFamily="18" charset="0"/>
               </a:rPr>
-              <a:t>Provides a visual and logical representation of tasks, making complex systems easier to understand</a:t>
-            </a:r>
-            <a:r>
-              <a:rPr lang="en-US" sz="2000" dirty="0" smtClean="0">
-                <a:latin typeface="Times New Roman" panose="02020603050405020304" pitchFamily="18" charset="0"/>
-                <a:cs typeface="Times New Roman" panose="02020603050405020304" pitchFamily="18" charset="0"/>
-              </a:rPr>
-              <a:t>.</a:t>
+              <a:t>Provides a visual and logical representation of tasks, making complex systems easier to understand.</a:t>
             </a:r>
           </a:p>
           <a:p>
@@ -20886,32 +20828,18 @@
               <a:buNone/>
             </a:pPr>
             <a:r>
-              <a:rPr lang="en-US" sz="2000" b="1" dirty="0" smtClean="0">
-                <a:latin typeface="Times New Roman" panose="02020603050405020304" pitchFamily="18" charset="0"/>
-                <a:cs typeface="Times New Roman" panose="02020603050405020304" pitchFamily="18" charset="0"/>
-              </a:rPr>
-              <a:t>Cost-Effective</a:t>
-            </a:r>
-            <a:r>
               <a:rPr lang="en-US" sz="2000" b="1" dirty="0">
                 <a:latin typeface="Times New Roman" panose="02020603050405020304" pitchFamily="18" charset="0"/>
                 <a:cs typeface="Times New Roman" panose="02020603050405020304" pitchFamily="18" charset="0"/>
               </a:rPr>
-              <a:t>: </a:t>
+              <a:t>Cost-Effective: </a:t>
             </a:r>
             <a:r>
               <a:rPr lang="en-US" sz="2000" dirty="0">
                 <a:latin typeface="Times New Roman" panose="02020603050405020304" pitchFamily="18" charset="0"/>
                 <a:cs typeface="Times New Roman" panose="02020603050405020304" pitchFamily="18" charset="0"/>
               </a:rPr>
-              <a:t>Less expensive than more formal or heavyweight methods</a:t>
-            </a:r>
-            <a:r>
-              <a:rPr lang="en-US" sz="2000" dirty="0" smtClean="0">
-                <a:latin typeface="Times New Roman" panose="02020603050405020304" pitchFamily="18" charset="0"/>
-                <a:cs typeface="Times New Roman" panose="02020603050405020304" pitchFamily="18" charset="0"/>
-              </a:rPr>
-              <a:t>.</a:t>
+              <a:t>Less expensive than more formal or heavyweight methods.</a:t>
             </a:r>
           </a:p>
           <a:p>
@@ -20919,32 +20847,18 @@
               <a:buNone/>
             </a:pPr>
             <a:r>
-              <a:rPr lang="en-US" sz="2000" b="1" dirty="0" smtClean="0">
-                <a:latin typeface="Times New Roman" panose="02020603050405020304" pitchFamily="18" charset="0"/>
-                <a:cs typeface="Times New Roman" panose="02020603050405020304" pitchFamily="18" charset="0"/>
-              </a:rPr>
-              <a:t>Process-Oriented</a:t>
-            </a:r>
-            <a:r>
               <a:rPr lang="en-US" sz="2000" b="1" dirty="0">
                 <a:latin typeface="Times New Roman" panose="02020603050405020304" pitchFamily="18" charset="0"/>
                 <a:cs typeface="Times New Roman" panose="02020603050405020304" pitchFamily="18" charset="0"/>
               </a:rPr>
-              <a:t>: </a:t>
+              <a:t>Process-Oriented: </a:t>
             </a:r>
             <a:r>
               <a:rPr lang="en-US" sz="2000" dirty="0">
                 <a:latin typeface="Times New Roman" panose="02020603050405020304" pitchFamily="18" charset="0"/>
                 <a:cs typeface="Times New Roman" panose="02020603050405020304" pitchFamily="18" charset="0"/>
               </a:rPr>
-              <a:t>Focuses on how data moves and changes over time</a:t>
-            </a:r>
-            <a:r>
-              <a:rPr lang="en-US" sz="2000" dirty="0" smtClean="0">
-                <a:latin typeface="Times New Roman" panose="02020603050405020304" pitchFamily="18" charset="0"/>
-                <a:cs typeface="Times New Roman" panose="02020603050405020304" pitchFamily="18" charset="0"/>
-              </a:rPr>
-              <a:t>.</a:t>
+              <a:t>Focuses on how data moves and changes over time.</a:t>
             </a:r>
           </a:p>
           <a:p>
@@ -20952,37 +20866,19 @@
               <a:buNone/>
             </a:pPr>
             <a:r>
-              <a:rPr lang="en-US" sz="2000" b="1" dirty="0" smtClean="0">
-                <a:latin typeface="Times New Roman" panose="02020603050405020304" pitchFamily="18" charset="0"/>
-                <a:cs typeface="Times New Roman" panose="02020603050405020304" pitchFamily="18" charset="0"/>
-              </a:rPr>
-              <a:t>Ideal </a:t>
-            </a:r>
-            <a:r>
               <a:rPr lang="en-US" sz="2000" b="1" dirty="0">
                 <a:latin typeface="Times New Roman" panose="02020603050405020304" pitchFamily="18" charset="0"/>
                 <a:cs typeface="Times New Roman" panose="02020603050405020304" pitchFamily="18" charset="0"/>
               </a:rPr>
-              <a:t>for Analysis &amp; Design: </a:t>
+              <a:t>Ideal for Analysis &amp; Design: </a:t>
             </a:r>
             <a:r>
               <a:rPr lang="en-US" sz="2000" dirty="0">
                 <a:latin typeface="Times New Roman" panose="02020603050405020304" pitchFamily="18" charset="0"/>
                 <a:cs typeface="Times New Roman" panose="02020603050405020304" pitchFamily="18" charset="0"/>
               </a:rPr>
-              <a:t>Especially useful in early stages of system development</a:t>
-            </a:r>
-            <a:r>
-              <a:rPr lang="en-US" sz="2000" dirty="0" smtClean="0">
-                <a:latin typeface="Times New Roman" panose="02020603050405020304" pitchFamily="18" charset="0"/>
-                <a:cs typeface="Times New Roman" panose="02020603050405020304" pitchFamily="18" charset="0"/>
-              </a:rPr>
-              <a:t>.</a:t>
-            </a:r>
-            <a:endParaRPr lang="en-US" sz="2000" dirty="0">
-              <a:latin typeface="Times New Roman" panose="02020603050405020304" pitchFamily="18" charset="0"/>
-              <a:cs typeface="Times New Roman" panose="02020603050405020304" pitchFamily="18" charset="0"/>
-            </a:endParaRPr>
+              <a:t>Especially useful in early stages of system development.</a:t>
+            </a:r>
           </a:p>
         </p:txBody>
       </p:sp>
@@ -21081,83 +20977,34 @@
                 <a:latin typeface="Times New Roman" panose="02020603050405020304" pitchFamily="18" charset="0"/>
                 <a:cs typeface="Times New Roman" panose="02020603050405020304" pitchFamily="18" charset="0"/>
               </a:rPr>
-              <a:t>Used for</a:t>
-            </a:r>
-            <a:r>
-              <a:rPr lang="en-US" sz="2000" b="1" dirty="0" smtClean="0">
-                <a:latin typeface="Times New Roman" panose="02020603050405020304" pitchFamily="18" charset="0"/>
-                <a:cs typeface="Times New Roman" panose="02020603050405020304" pitchFamily="18" charset="0"/>
-              </a:rPr>
-              <a:t>:</a:t>
-            </a:r>
-          </a:p>
-          <a:p>
-            <a:r>
-              <a:rPr lang="en-US" sz="2000" dirty="0" smtClean="0">
-                <a:latin typeface="Times New Roman" panose="02020603050405020304" pitchFamily="18" charset="0"/>
-                <a:cs typeface="Times New Roman" panose="02020603050405020304" pitchFamily="18" charset="0"/>
-              </a:rPr>
-              <a:t>Designing </a:t>
-            </a:r>
+              <a:t>Used for:</a:t>
+            </a:r>
+          </a:p>
+          <a:p>
             <a:r>
               <a:rPr lang="en-US" sz="2000" dirty="0">
                 <a:latin typeface="Times New Roman" panose="02020603050405020304" pitchFamily="18" charset="0"/>
                 <a:cs typeface="Times New Roman" panose="02020603050405020304" pitchFamily="18" charset="0"/>
               </a:rPr>
-              <a:t>dialog flows in interactive </a:t>
-            </a:r>
-            <a:r>
-              <a:rPr lang="en-US" sz="2000" dirty="0" smtClean="0">
-                <a:latin typeface="Times New Roman" panose="02020603050405020304" pitchFamily="18" charset="0"/>
-                <a:cs typeface="Times New Roman" panose="02020603050405020304" pitchFamily="18" charset="0"/>
-              </a:rPr>
-              <a:t>systems</a:t>
-            </a:r>
-          </a:p>
-          <a:p>
-            <a:r>
-              <a:rPr lang="en-US" sz="2000" dirty="0" smtClean="0">
-                <a:latin typeface="Times New Roman" panose="02020603050405020304" pitchFamily="18" charset="0"/>
-                <a:cs typeface="Times New Roman" panose="02020603050405020304" pitchFamily="18" charset="0"/>
-              </a:rPr>
-              <a:t>Mapping </a:t>
-            </a:r>
+              <a:t>Designing dialog flows in interactive systems</a:t>
+            </a:r>
+          </a:p>
+          <a:p>
             <a:r>
               <a:rPr lang="en-US" sz="2000" dirty="0">
                 <a:latin typeface="Times New Roman" panose="02020603050405020304" pitchFamily="18" charset="0"/>
                 <a:cs typeface="Times New Roman" panose="02020603050405020304" pitchFamily="18" charset="0"/>
               </a:rPr>
-              <a:t>user tasks to system </a:t>
-            </a:r>
-            <a:r>
-              <a:rPr lang="en-US" sz="2000" dirty="0" smtClean="0">
-                <a:latin typeface="Times New Roman" panose="02020603050405020304" pitchFamily="18" charset="0"/>
-                <a:cs typeface="Times New Roman" panose="02020603050405020304" pitchFamily="18" charset="0"/>
-              </a:rPr>
-              <a:t>functions</a:t>
-            </a:r>
-          </a:p>
-          <a:p>
-            <a:r>
-              <a:rPr lang="en-US" sz="2000" dirty="0" smtClean="0">
-                <a:latin typeface="Times New Roman" panose="02020603050405020304" pitchFamily="18" charset="0"/>
-                <a:cs typeface="Times New Roman" panose="02020603050405020304" pitchFamily="18" charset="0"/>
-              </a:rPr>
-              <a:t>Creating </a:t>
-            </a:r>
+              <a:t>Mapping user tasks to system functions</a:t>
+            </a:r>
+          </a:p>
+          <a:p>
             <a:r>
               <a:rPr lang="en-US" sz="2000" dirty="0">
                 <a:latin typeface="Times New Roman" panose="02020603050405020304" pitchFamily="18" charset="0"/>
                 <a:cs typeface="Times New Roman" panose="02020603050405020304" pitchFamily="18" charset="0"/>
               </a:rPr>
-              <a:t>structured data-process </a:t>
-            </a:r>
-            <a:r>
-              <a:rPr lang="en-US" sz="2000" dirty="0" smtClean="0">
-                <a:latin typeface="Times New Roman" panose="02020603050405020304" pitchFamily="18" charset="0"/>
-                <a:cs typeface="Times New Roman" panose="02020603050405020304" pitchFamily="18" charset="0"/>
-              </a:rPr>
-              <a:t>diagrams</a:t>
+              <a:t>Creating structured data-process diagrams</a:t>
             </a:r>
           </a:p>
           <a:p>
@@ -21165,110 +21012,47 @@
               <a:buNone/>
             </a:pPr>
             <a:r>
-              <a:rPr lang="en-US" sz="2000" b="1" dirty="0" smtClean="0">
-                <a:latin typeface="Times New Roman" panose="02020603050405020304" pitchFamily="18" charset="0"/>
-                <a:cs typeface="Times New Roman" panose="02020603050405020304" pitchFamily="18" charset="0"/>
-              </a:rPr>
-              <a:t>Example </a:t>
-            </a:r>
-            <a:r>
               <a:rPr lang="en-US" sz="2000" b="1" dirty="0">
                 <a:latin typeface="Times New Roman" panose="02020603050405020304" pitchFamily="18" charset="0"/>
                 <a:cs typeface="Times New Roman" panose="02020603050405020304" pitchFamily="18" charset="0"/>
               </a:rPr>
-              <a:t>Application: Personal Record </a:t>
-            </a:r>
-            <a:r>
-              <a:rPr lang="en-US" sz="2000" b="1" dirty="0" smtClean="0">
-                <a:latin typeface="Times New Roman" panose="02020603050405020304" pitchFamily="18" charset="0"/>
-                <a:cs typeface="Times New Roman" panose="02020603050405020304" pitchFamily="18" charset="0"/>
-              </a:rPr>
-              <a:t>System</a:t>
-            </a:r>
-          </a:p>
-          <a:p>
-            <a:r>
-              <a:rPr lang="en-US" sz="2000" dirty="0" smtClean="0">
-                <a:latin typeface="Times New Roman" panose="02020603050405020304" pitchFamily="18" charset="0"/>
-                <a:cs typeface="Times New Roman" panose="02020603050405020304" pitchFamily="18" charset="0"/>
-              </a:rPr>
-              <a:t>In </a:t>
-            </a:r>
+              <a:t>Example Application: Personal Record System</a:t>
+            </a:r>
+          </a:p>
+          <a:p>
             <a:r>
               <a:rPr lang="en-US" sz="2000" dirty="0">
                 <a:latin typeface="Times New Roman" panose="02020603050405020304" pitchFamily="18" charset="0"/>
                 <a:cs typeface="Times New Roman" panose="02020603050405020304" pitchFamily="18" charset="0"/>
               </a:rPr>
-              <a:t>such a system, JSD could be used to</a:t>
-            </a:r>
-            <a:r>
-              <a:rPr lang="en-US" sz="2000" dirty="0" smtClean="0">
-                <a:latin typeface="Times New Roman" panose="02020603050405020304" pitchFamily="18" charset="0"/>
-                <a:cs typeface="Times New Roman" panose="02020603050405020304" pitchFamily="18" charset="0"/>
-              </a:rPr>
-              <a:t>:</a:t>
-            </a:r>
-          </a:p>
-          <a:p>
-            <a:r>
-              <a:rPr lang="en-US" sz="2000" dirty="0" smtClean="0">
-                <a:latin typeface="Times New Roman" panose="02020603050405020304" pitchFamily="18" charset="0"/>
-                <a:cs typeface="Times New Roman" panose="02020603050405020304" pitchFamily="18" charset="0"/>
-              </a:rPr>
-              <a:t>Break </a:t>
-            </a:r>
+              <a:t>In such a system, JSD could be used to:</a:t>
+            </a:r>
+          </a:p>
+          <a:p>
             <a:r>
               <a:rPr lang="en-US" sz="2000" dirty="0">
                 <a:latin typeface="Times New Roman" panose="02020603050405020304" pitchFamily="18" charset="0"/>
                 <a:cs typeface="Times New Roman" panose="02020603050405020304" pitchFamily="18" charset="0"/>
               </a:rPr>
-              <a:t>down tasks like Add Record, Update Record, Delete </a:t>
-            </a:r>
-            <a:r>
-              <a:rPr lang="en-US" sz="2000" dirty="0" smtClean="0">
-                <a:latin typeface="Times New Roman" panose="02020603050405020304" pitchFamily="18" charset="0"/>
-                <a:cs typeface="Times New Roman" panose="02020603050405020304" pitchFamily="18" charset="0"/>
-              </a:rPr>
-              <a:t>Record</a:t>
-            </a:r>
-          </a:p>
-          <a:p>
-            <a:r>
-              <a:rPr lang="en-US" sz="2000" dirty="0" smtClean="0">
-                <a:latin typeface="Times New Roman" panose="02020603050405020304" pitchFamily="18" charset="0"/>
-                <a:cs typeface="Times New Roman" panose="02020603050405020304" pitchFamily="18" charset="0"/>
-              </a:rPr>
-              <a:t>Analyze </a:t>
-            </a:r>
+              <a:t>Break down tasks like Add Record, Update Record, Delete Record</a:t>
+            </a:r>
+          </a:p>
+          <a:p>
             <a:r>
               <a:rPr lang="en-US" sz="2000" dirty="0">
                 <a:latin typeface="Times New Roman" panose="02020603050405020304" pitchFamily="18" charset="0"/>
                 <a:cs typeface="Times New Roman" panose="02020603050405020304" pitchFamily="18" charset="0"/>
               </a:rPr>
-              <a:t>user dialogs for searching or viewing personal </a:t>
-            </a:r>
-            <a:r>
-              <a:rPr lang="en-US" sz="2000" dirty="0" smtClean="0">
-                <a:latin typeface="Times New Roman" panose="02020603050405020304" pitchFamily="18" charset="0"/>
-                <a:cs typeface="Times New Roman" panose="02020603050405020304" pitchFamily="18" charset="0"/>
-              </a:rPr>
-              <a:t>data</a:t>
-            </a:r>
-          </a:p>
-          <a:p>
-            <a:r>
-              <a:rPr lang="en-US" sz="2000" dirty="0" smtClean="0">
-                <a:latin typeface="Times New Roman" panose="02020603050405020304" pitchFamily="18" charset="0"/>
-                <a:cs typeface="Times New Roman" panose="02020603050405020304" pitchFamily="18" charset="0"/>
-              </a:rPr>
-              <a:t>Model </a:t>
-            </a:r>
+              <a:t>Analyze user dialogs for searching or viewing personal data</a:t>
+            </a:r>
+          </a:p>
+          <a:p>
             <a:r>
               <a:rPr lang="en-US" sz="2000" dirty="0">
                 <a:latin typeface="Times New Roman" panose="02020603050405020304" pitchFamily="18" charset="0"/>
                 <a:cs typeface="Times New Roman" panose="02020603050405020304" pitchFamily="18" charset="0"/>
               </a:rPr>
-              <a:t>the process life cycle of a "Person" object</a:t>
+              <a:t>Model the process life cycle of a "Person" object</a:t>
             </a:r>
           </a:p>
         </p:txBody>
@@ -21935,14 +21719,7 @@
                 <a:latin typeface="Times New Roman" panose="02020603050405020304" pitchFamily="18" charset="0"/>
                 <a:cs typeface="Times New Roman" panose="02020603050405020304" pitchFamily="18" charset="0"/>
               </a:rPr>
-              <a:t> regardless of their physical location</a:t>
-            </a:r>
-            <a:r>
-              <a:rPr lang="en-US" sz="2400" dirty="0" smtClean="0">
-                <a:latin typeface="Times New Roman" panose="02020603050405020304" pitchFamily="18" charset="0"/>
-                <a:cs typeface="Times New Roman" panose="02020603050405020304" pitchFamily="18" charset="0"/>
-              </a:rPr>
-              <a:t>.</a:t>
+              <a:t> regardless of their physical location.</a:t>
             </a:r>
           </a:p>
           <a:p>
@@ -21950,18 +21727,11 @@
               <a:buNone/>
             </a:pPr>
             <a:r>
-              <a:rPr lang="en-US" sz="2600" b="1" dirty="0" smtClean="0">
-                <a:latin typeface="Times New Roman" panose="02020603050405020304" pitchFamily="18" charset="0"/>
-                <a:cs typeface="Times New Roman" panose="02020603050405020304" pitchFamily="18" charset="0"/>
-              </a:rPr>
-              <a:t>1</a:t>
-            </a:r>
-            <a:r>
               <a:rPr lang="en-US" sz="2600" b="1" dirty="0">
                 <a:latin typeface="Times New Roman" panose="02020603050405020304" pitchFamily="18" charset="0"/>
                 <a:cs typeface="Times New Roman" panose="02020603050405020304" pitchFamily="18" charset="0"/>
               </a:rPr>
-              <a:t>: Asynchronous Communication</a:t>
+              <a:t>1: Asynchronous Communication</a:t>
             </a:r>
           </a:p>
           <a:p>
@@ -21969,18 +21739,11 @@
               <a:buNone/>
             </a:pPr>
             <a:r>
-              <a:rPr lang="en-US" sz="2600" dirty="0" smtClean="0">
-                <a:latin typeface="Times New Roman" panose="02020603050405020304" pitchFamily="18" charset="0"/>
-                <a:cs typeface="Times New Roman" panose="02020603050405020304" pitchFamily="18" charset="0"/>
-              </a:rPr>
-              <a:t>Communication </a:t>
-            </a:r>
-            <a:r>
               <a:rPr lang="en-US" sz="2600" dirty="0">
                 <a:latin typeface="Times New Roman" panose="02020603050405020304" pitchFamily="18" charset="0"/>
                 <a:cs typeface="Times New Roman" panose="02020603050405020304" pitchFamily="18" charset="0"/>
               </a:rPr>
-              <a:t>that does </a:t>
+              <a:t>Communication that does </a:t>
             </a:r>
             <a:r>
               <a:rPr lang="en-US" sz="2600" b="1" dirty="0">
@@ -22236,18 +21999,11 @@
               <a:buNone/>
             </a:pPr>
             <a:r>
-              <a:rPr lang="en-US" dirty="0" smtClean="0">
-                <a:latin typeface="Times New Roman" panose="02020603050405020304" pitchFamily="18" charset="0"/>
-                <a:cs typeface="Times New Roman" panose="02020603050405020304" pitchFamily="18" charset="0"/>
-              </a:rPr>
-              <a:t>Communication </a:t>
-            </a:r>
-            <a:r>
               <a:rPr lang="en-US" dirty="0">
                 <a:latin typeface="Times New Roman" panose="02020603050405020304" pitchFamily="18" charset="0"/>
                 <a:cs typeface="Times New Roman" panose="02020603050405020304" pitchFamily="18" charset="0"/>
               </a:rPr>
-              <a:t>that happens in </a:t>
+              <a:t>Communication that happens in </a:t>
             </a:r>
             <a:r>
               <a:rPr lang="en-US" b="1" dirty="0">
@@ -22495,13 +22251,6 @@
               </a:rPr>
               <a:t>Email</a:t>
             </a:r>
-            <a:r>
-              <a:rPr lang="en-US" dirty="0">
-                <a:latin typeface="Times New Roman" panose="02020603050405020304" pitchFamily="18" charset="0"/>
-                <a:cs typeface="Times New Roman" panose="02020603050405020304" pitchFamily="18" charset="0"/>
-              </a:rPr>
-              <a:t/>
-            </a:r>
             <a:br>
               <a:rPr lang="en-US" dirty="0">
                 <a:latin typeface="Times New Roman" panose="02020603050405020304" pitchFamily="18" charset="0"/>
@@ -22524,13 +22273,6 @@
               </a:rPr>
               <a:t>Messaging Systems</a:t>
             </a:r>
-            <a:r>
-              <a:rPr lang="en-US" dirty="0">
-                <a:latin typeface="Times New Roman" panose="02020603050405020304" pitchFamily="18" charset="0"/>
-                <a:cs typeface="Times New Roman" panose="02020603050405020304" pitchFamily="18" charset="0"/>
-              </a:rPr>
-              <a:t/>
-            </a:r>
             <a:br>
               <a:rPr lang="en-US" dirty="0">
                 <a:latin typeface="Times New Roman" panose="02020603050405020304" pitchFamily="18" charset="0"/>
@@ -22567,13 +22309,6 @@
               </a:rPr>
               <a:t>Video Conferencing</a:t>
             </a:r>
-            <a:r>
-              <a:rPr lang="en-US" dirty="0">
-                <a:latin typeface="Times New Roman" panose="02020603050405020304" pitchFamily="18" charset="0"/>
-                <a:cs typeface="Times New Roman" panose="02020603050405020304" pitchFamily="18" charset="0"/>
-              </a:rPr>
-              <a:t/>
-            </a:r>
             <a:br>
               <a:rPr lang="en-US" dirty="0">
                 <a:latin typeface="Times New Roman" panose="02020603050405020304" pitchFamily="18" charset="0"/>
@@ -22595,13 +22330,6 @@
                 <a:cs typeface="Times New Roman" panose="02020603050405020304" pitchFamily="18" charset="0"/>
               </a:rPr>
               <a:t>Virtual Collaborative Environments</a:t>
-            </a:r>
-            <a:r>
-              <a:rPr lang="en-US" dirty="0">
-                <a:latin typeface="Times New Roman" panose="02020603050405020304" pitchFamily="18" charset="0"/>
-                <a:cs typeface="Times New Roman" panose="02020603050405020304" pitchFamily="18" charset="0"/>
-              </a:rPr>
-              <a:t/>
             </a:r>
             <a:br>
               <a:rPr lang="en-US" dirty="0">
@@ -23504,14 +23232,7 @@
                 <a:latin typeface="Times New Roman" panose="02020603050405020304" pitchFamily="18" charset="0"/>
                 <a:cs typeface="Times New Roman" panose="02020603050405020304" pitchFamily="18" charset="0"/>
               </a:rPr>
-              <a:t>This slide is drawing an analogy between how we “speak” to a computer (write code) and how we speak to each other, breaking both into three levels</a:t>
-            </a:r>
-            <a:r>
-              <a:rPr lang="en-US" sz="2000" dirty="0" smtClean="0">
-                <a:latin typeface="Times New Roman" panose="02020603050405020304" pitchFamily="18" charset="0"/>
-                <a:cs typeface="Times New Roman" panose="02020603050405020304" pitchFamily="18" charset="0"/>
-              </a:rPr>
-              <a:t>:</a:t>
+              <a:t>This slide is drawing an analogy between how we “speak” to a computer (write code) and how we speak to each other, breaking both into three levels:</a:t>
             </a:r>
           </a:p>
           <a:p>
@@ -23519,7 +23240,7 @@
               <a:buAutoNum type="arabicPeriod"/>
             </a:pPr>
             <a:r>
-              <a:rPr lang="en-US" sz="2000" b="1" dirty="0" smtClean="0">
+              <a:rPr lang="en-US" sz="2000" b="1" dirty="0">
                 <a:latin typeface="Times New Roman" panose="02020603050405020304" pitchFamily="18" charset="0"/>
                 <a:cs typeface="Times New Roman" panose="02020603050405020304" pitchFamily="18" charset="0"/>
               </a:rPr>
@@ -23531,32 +23252,18 @@
               <a:buNone/>
             </a:pPr>
             <a:r>
-              <a:rPr lang="en-US" sz="2000" b="1" dirty="0" smtClean="0">
-                <a:latin typeface="Times New Roman" panose="02020603050405020304" pitchFamily="18" charset="0"/>
-                <a:cs typeface="Times New Roman" panose="02020603050405020304" pitchFamily="18" charset="0"/>
-              </a:rPr>
-              <a:t>Computer </a:t>
-            </a:r>
-            <a:r>
               <a:rPr lang="en-US" sz="2000" b="1" dirty="0">
                 <a:latin typeface="Times New Roman" panose="02020603050405020304" pitchFamily="18" charset="0"/>
                 <a:cs typeface="Times New Roman" panose="02020603050405020304" pitchFamily="18" charset="0"/>
               </a:rPr>
-              <a:t>side: </a:t>
+              <a:t>Computer side: </a:t>
             </a:r>
             <a:r>
               <a:rPr lang="en-US" sz="2000" dirty="0">
                 <a:latin typeface="Times New Roman" panose="02020603050405020304" pitchFamily="18" charset="0"/>
                 <a:cs typeface="Times New Roman" panose="02020603050405020304" pitchFamily="18" charset="0"/>
               </a:rPr>
-              <a:t>the raw symbols—what characters you type (if, (, x, &gt;, 0, ), { …), or even the pixels on screen that represent them</a:t>
-            </a:r>
-            <a:r>
-              <a:rPr lang="en-US" sz="2000" dirty="0" smtClean="0">
-                <a:latin typeface="Times New Roman" panose="02020603050405020304" pitchFamily="18" charset="0"/>
-                <a:cs typeface="Times New Roman" panose="02020603050405020304" pitchFamily="18" charset="0"/>
-              </a:rPr>
-              <a:t>.</a:t>
+              <a:t>the raw symbols—what characters you type (if, (, x, &gt;, 0, ), { …), or even the pixels on screen that represent them.</a:t>
             </a:r>
           </a:p>
           <a:p>
@@ -23564,18 +23271,11 @@
               <a:buNone/>
             </a:pPr>
             <a:r>
-              <a:rPr lang="en-US" sz="2000" b="1" dirty="0" smtClean="0">
-                <a:latin typeface="Times New Roman" panose="02020603050405020304" pitchFamily="18" charset="0"/>
-                <a:cs typeface="Times New Roman" panose="02020603050405020304" pitchFamily="18" charset="0"/>
-              </a:rPr>
-              <a:t>Human-language </a:t>
-            </a:r>
-            <a:r>
               <a:rPr lang="en-US" sz="2000" b="1" dirty="0">
                 <a:latin typeface="Times New Roman" panose="02020603050405020304" pitchFamily="18" charset="0"/>
                 <a:cs typeface="Times New Roman" panose="02020603050405020304" pitchFamily="18" charset="0"/>
               </a:rPr>
-              <a:t>analogy: </a:t>
+              <a:t>Human-language analogy: </a:t>
             </a:r>
             <a:r>
               <a:rPr lang="en-US" sz="2000" dirty="0">
@@ -23592,7 +23292,7 @@
               <a:t>kat</a:t>
             </a:r>
             <a:r>
-              <a:rPr lang="en-US" sz="2000" dirty="0" smtClean="0">
+              <a:rPr lang="en-US" sz="2000" dirty="0">
                 <a:latin typeface="Times New Roman" panose="02020603050405020304" pitchFamily="18" charset="0"/>
                 <a:cs typeface="Times New Roman" panose="02020603050405020304" pitchFamily="18" charset="0"/>
               </a:rPr>
@@ -23604,18 +23304,11 @@
               <a:buNone/>
             </a:pPr>
             <a:r>
-              <a:rPr lang="en-US" sz="2000" b="1" dirty="0" smtClean="0">
-                <a:latin typeface="Times New Roman" panose="02020603050405020304" pitchFamily="18" charset="0"/>
-                <a:cs typeface="Times New Roman" panose="02020603050405020304" pitchFamily="18" charset="0"/>
-              </a:rPr>
-              <a:t>In </a:t>
-            </a:r>
-            <a:r>
               <a:rPr lang="en-US" sz="2000" b="1" dirty="0">
                 <a:latin typeface="Times New Roman" panose="02020603050405020304" pitchFamily="18" charset="0"/>
                 <a:cs typeface="Times New Roman" panose="02020603050405020304" pitchFamily="18" charset="0"/>
               </a:rPr>
-              <a:t>practice: </a:t>
+              <a:t>In practice: </a:t>
             </a:r>
             <a:r>
               <a:rPr lang="en-US" sz="2000" dirty="0">
@@ -23636,14 +23329,7 @@
                 <a:latin typeface="Times New Roman" panose="02020603050405020304" pitchFamily="18" charset="0"/>
                 <a:cs typeface="Times New Roman" panose="02020603050405020304" pitchFamily="18" charset="0"/>
               </a:rPr>
-              <a:t> (or scanner) groups characters into tokens like identifiers, keywords, operators, literals</a:t>
-            </a:r>
-            <a:r>
-              <a:rPr lang="en-US" sz="2000" dirty="0" smtClean="0">
-                <a:latin typeface="Times New Roman" panose="02020603050405020304" pitchFamily="18" charset="0"/>
-                <a:cs typeface="Times New Roman" panose="02020603050405020304" pitchFamily="18" charset="0"/>
-              </a:rPr>
-              <a:t>.</a:t>
+              <a:t> (or scanner) groups characters into tokens like identifiers, keywords, operators, literals.</a:t>
             </a:r>
           </a:p>
           <a:p>
@@ -23651,7 +23337,7 @@
               <a:buNone/>
             </a:pPr>
             <a:r>
-              <a:rPr lang="en-US" sz="2000" dirty="0" smtClean="0">
+              <a:rPr lang="en-US" sz="2000" dirty="0">
                 <a:latin typeface="Times New Roman" panose="02020603050405020304" pitchFamily="18" charset="0"/>
                 <a:cs typeface="Times New Roman" panose="02020603050405020304" pitchFamily="18" charset="0"/>
               </a:rPr>

</xml_diff>